<commit_message>
Set author and affiliation, add independence statement, fix cover layout, add refresh script
Co-Authored-By: Claude Sonnet 5.5 <noreply@anthropic.com>
Claude-Session: https://claude.ai/code/session_01DpzzGnkWza5edjMiHiost1
</commit_message>
<xml_diff>
--- a/echo-essentials/dist/2_Echo_Essentials_Teaching_Slides.pptx
+++ b/echo-essentials/dist/2_Echo_Essentials_Teaching_Slides.pptx
@@ -5261,7 +5261,7 @@
                 </a:solidFill>
                 <a:latin typeface="Cambria"/>
               </a:rPr>
-              <a:t>Dr. [Your Name]</a:t>
+              <a:t>Dr. Elfadil Bilal Abdelrahman</a:t>
             </a:r>
           </a:p>
         </p:txBody>
@@ -5296,7 +5296,7 @@
                 </a:solidFill>
                 <a:latin typeface="Calibri"/>
               </a:rPr>
-              <a:t>Consultant Cardiologist and Echocardiographer</a:t>
+              <a:t>Consultant Cardiologist and Echocardiographer, Prince Mohammed bin Abdulaziz Hospital, Riyadh</a:t>
             </a:r>
           </a:p>
         </p:txBody>
@@ -16719,7 +16719,7 @@
                 </a:solidFill>
                 <a:latin typeface="Calibri"/>
               </a:rPr>
-              <a:t>Dr. [Your Name]   /   Echo Essentials   /   Verify thresholds against current guideline editions.</a:t>
+              <a:t>Dr. Elfadil Bilal Abdelrahman   /   Echo Essentials   /   Verify thresholds against current guideline editions.</a:t>
             </a:r>
           </a:p>
         </p:txBody>

</xml_diff>